<commit_message>
Update PPT for wiki mcp
</commit_message>
<xml_diff>
--- a/docs/IAM_Assistant_Overview.pptx
+++ b/docs/IAM_Assistant_Overview.pptx
@@ -10386,7 +10386,7 @@
                 </a:solidFill>
                 <a:latin typeface="Calibri"/>
               </a:rPr>
-              <a:t>Plus  /iam-wiki  — SAP Confluence wiki researcher (CLI-only; not exposed in the Web UI).</a:t>
+              <a:t>Plus  /iam-wiki  — SAP Confluence wiki researcher (available in both CLI and Web UI; SAP internal network required).</a:t>
             </a:r>
           </a:p>
         </p:txBody>
@@ -26147,7 +26147,7 @@
                           </a:solidFill>
                           <a:latin typeface="Calibri"/>
                         </a:rPr>
-                        <a:t>Subprocess over stdio (er6_mcp_server.py)</a:t>
+                        <a:t>Subprocess over stdio — er6 (6 tools) + sap-wiki (4 tools)</a:t>
                       </a:r>
                     </a:p>
                   </a:txBody>
@@ -26742,7 +26742,7 @@
                 </a:solidFill>
                 <a:latin typeface="Calibri"/>
               </a:rPr>
-              <a:t>Scope: live ER6 only.</a:t>
+              <a:t>Wiki access.</a:t>
             </a:r>
             <a:r>
               <a:rPr sz="1000">
@@ -26751,7 +26751,44 @@
                 </a:solidFill>
                 <a:latin typeface="Calibri"/>
               </a:rPr>
-              <a:t>  /iam-wiki and SAP Confluence access are CLI-only — wiki is a research surface, not an end-user one.</a:t>
+              <a:t>  /iam-wiki and SAP Confluence available in both CLI and Web UI via sap-wiki MCP.</a:t>
+            </a:r>
+          </a:p>
+          <a:p>
+            <a:pPr algn="l">
+              <a:lnSpc>
+                <a:spcPct val="115000"/>
+              </a:lnSpc>
+              <a:spcAft>
+                <a:spcPts val="400"/>
+              </a:spcAft>
+            </a:pPr>
+            <a:r>
+              <a:rPr sz="1000" b="1">
+                <a:solidFill>
+                  <a:srgbClr val="2E86C1"/>
+                </a:solidFill>
+                <a:latin typeface="Calibri"/>
+              </a:rPr>
+              <a:t>▸  </a:t>
+            </a:r>
+            <a:r>
+              <a:rPr sz="1000" b="1">
+                <a:solidFill>
+                  <a:srgbClr val="1E3A5F"/>
+                </a:solidFill>
+                <a:latin typeface="Calibri"/>
+              </a:rPr>
+              <a:t>Connection status.</a:t>
+            </a:r>
+            <a:r>
+              <a:rPr sz="1000">
+                <a:solidFill>
+                  <a:srgbClr val="333333"/>
+                </a:solidFill>
+                <a:latin typeface="Calibri"/>
+              </a:rPr>
+              <a:t>  Header shows ER6 and Wiki status independently (green = connected).</a:t>
             </a:r>
           </a:p>
           <a:p>
@@ -39078,6 +39115,7 @@
               </a:rPr>
               <a:t>Interactive command-line assistant powered by Claude Opus.
 •  Domain skills: /treasury-iam, /cash-iam, /fin-iam
+•  Wiki researcher: /iam-wiki (SAP Confluence via sap-wiki MCP)
 •  Goal-driven autonomous agent: /goal + /execute
 •  Persistent memo system: /memo
 •  Quality enforcement via three lifecycle hooks
@@ -39244,6 +39282,8 @@
               </a:rPr>
               <a:t>Browser-based chat UI built on FastAPI.
 •  Same Claude model, same MCP tools as the CLI
+•  ER6 + SAP Wiki access via MCPMultiClient (er6 + sap-wiki)
+•  Header shows ER6 and Wiki connection status independently
 •  OIDC authentication; per-user sessions
 •  Light / Dark theme (Catppuccin Latte / Mocha)
 •  Categorised prompt template library
@@ -41267,7 +41307,7 @@
                 </a:solidFill>
                 <a:latin typeface="Calibri"/>
               </a:rPr>
-              <a:t>Six ER6 tools exposed to Claude over stdio</a:t>
+              <a:t>ER6 data tools + SAP Wiki research tools — all over stdio</a:t>
             </a:r>
           </a:p>
         </p:txBody>
@@ -42010,8 +42050,8 @@
         </p:nvSpPr>
         <p:spPr>
           <a:xfrm>
-            <a:off x="365760" y="3977639"/>
-            <a:ext cx="11430000" cy="365760"/>
+            <a:off x="365760" y="3931920"/>
+            <a:ext cx="11430000" cy="320040"/>
           </a:xfrm>
           <a:prstGeom prst="rect">
             <a:avLst/>
@@ -42026,336 +42066,283 @@
           <a:p>
             <a:pPr algn="l"/>
             <a:r>
-              <a:rPr sz="1500" b="1">
+              <a:rPr sz="1300" b="1">
                 <a:solidFill>
                   <a:srgbClr val="1E3A5F"/>
                 </a:solidFill>
                 <a:latin typeface="Calibri"/>
               </a:rPr>
-              <a:t>ABAP Open SQL constraints  ·  what Claude knows to avoid</a:t>
-            </a:r>
-          </a:p>
-        </p:txBody>
-      </p:sp>
-      <p:sp>
-        <p:nvSpPr>
-          <p:cNvPr id="8" name="TextBox 7"/>
-          <p:cNvSpPr txBox="1"/>
-          <p:nvPr/>
-        </p:nvSpPr>
-        <p:spPr>
-          <a:xfrm>
-            <a:off x="365760" y="4389120"/>
-            <a:ext cx="11430000" cy="2011680"/>
-          </a:xfrm>
-          <a:prstGeom prst="rect">
-            <a:avLst/>
-          </a:prstGeom>
-          <a:noFill/>
-        </p:spPr>
-        <p:txBody>
-          <a:bodyPr wrap="square" lIns="45720" rIns="45720">
-            <a:spAutoFit/>
-          </a:bodyPr>
-          <a:lstStyle/>
-          <a:p>
-            <a:pPr algn="l">
-              <a:lnSpc>
-                <a:spcPct val="115000"/>
-              </a:lnSpc>
-              <a:spcAft>
-                <a:spcPts val="400"/>
-              </a:spcAft>
-            </a:pPr>
-            <a:r>
-              <a:rPr sz="1100" b="1">
-                <a:solidFill>
-                  <a:srgbClr val="E67E22"/>
-                </a:solidFill>
-                <a:latin typeface="Calibri"/>
-              </a:rPr>
-              <a:t>▸  </a:t>
-            </a:r>
-            <a:r>
-              <a:rPr sz="1100" b="1">
-                <a:solidFill>
-                  <a:srgbClr val="1E3A5F"/>
-                </a:solidFill>
-                <a:latin typeface="Calibri"/>
-              </a:rPr>
-              <a:t>No JOINs.</a:t>
-            </a:r>
-            <a:r>
-              <a:rPr sz="1100">
-                <a:solidFill>
-                  <a:srgbClr val="333333"/>
-                </a:solidFill>
-                <a:latin typeface="Calibri"/>
-              </a:rPr>
-              <a:t>  Run separate queries; correlate in memory — or use a CDS view that pre-joins.</a:t>
-            </a:r>
-          </a:p>
-          <a:p>
-            <a:pPr algn="l">
-              <a:lnSpc>
-                <a:spcPct val="115000"/>
-              </a:lnSpc>
-              <a:spcAft>
-                <a:spcPts val="400"/>
-              </a:spcAft>
-            </a:pPr>
-            <a:r>
-              <a:rPr sz="1100" b="1">
-                <a:solidFill>
-                  <a:srgbClr val="E67E22"/>
-                </a:solidFill>
-                <a:latin typeface="Calibri"/>
-              </a:rPr>
-              <a:t>▸  </a:t>
-            </a:r>
-            <a:r>
-              <a:rPr sz="1100" b="1">
-                <a:solidFill>
-                  <a:srgbClr val="1E3A5F"/>
-                </a:solidFill>
-                <a:latin typeface="Calibri"/>
-              </a:rPr>
-              <a:t>No subqueries.</a:t>
-            </a:r>
-            <a:r>
-              <a:rPr sz="1100">
-                <a:solidFill>
-                  <a:srgbClr val="333333"/>
-                </a:solidFill>
-                <a:latin typeface="Calibri"/>
-              </a:rPr>
-              <a:t>  Same — break into multiple round-trips.</a:t>
-            </a:r>
-          </a:p>
-          <a:p>
-            <a:pPr algn="l">
-              <a:lnSpc>
-                <a:spcPct val="115000"/>
-              </a:lnSpc>
-              <a:spcAft>
-                <a:spcPts val="400"/>
-              </a:spcAft>
-            </a:pPr>
-            <a:r>
-              <a:rPr sz="1100" b="1">
-                <a:solidFill>
-                  <a:srgbClr val="E67E22"/>
-                </a:solidFill>
-                <a:latin typeface="Calibri"/>
-              </a:rPr>
-              <a:t>▸  </a:t>
-            </a:r>
-            <a:r>
-              <a:rPr sz="1100" b="1">
-                <a:solidFill>
-                  <a:srgbClr val="1E3A5F"/>
-                </a:solidFill>
-                <a:latin typeface="Calibri"/>
-              </a:rPr>
-              <a:t>No table aliases (AS x).</a:t>
-            </a:r>
-            <a:r>
-              <a:rPr sz="1100">
-                <a:solidFill>
-                  <a:srgbClr val="333333"/>
-                </a:solidFill>
-                <a:latin typeface="Calibri"/>
-              </a:rPr>
-              <a:t>  Same error as JOIN — refer to columns by unqualified name.</a:t>
-            </a:r>
-          </a:p>
-          <a:p>
-            <a:pPr algn="l">
-              <a:lnSpc>
-                <a:spcPct val="115000"/>
-              </a:lnSpc>
-              <a:spcAft>
-                <a:spcPts val="400"/>
-              </a:spcAft>
-            </a:pPr>
-            <a:r>
-              <a:rPr sz="1100" b="1">
-                <a:solidFill>
-                  <a:srgbClr val="E67E22"/>
-                </a:solidFill>
-                <a:latin typeface="Calibri"/>
-              </a:rPr>
-              <a:t>▸  </a:t>
-            </a:r>
-            <a:r>
-              <a:rPr sz="1100" b="1">
-                <a:solidFill>
-                  <a:srgbClr val="1E3A5F"/>
-                </a:solidFill>
-                <a:latin typeface="Calibri"/>
-              </a:rPr>
-              <a:t>Long IN(...) lists fail at ~255 chars.</a:t>
-            </a:r>
-            <a:r>
-              <a:rPr sz="1100">
-                <a:solidFill>
-                  <a:srgbClr val="333333"/>
-                </a:solidFill>
-                <a:latin typeface="Calibri"/>
-              </a:rPr>
-              <a:t>  Use LIKE '&lt;prefix&gt;%' or BETWEEN '&lt;lo&gt;' AND '&lt;hi&gt;' instead.</a:t>
-            </a:r>
-          </a:p>
-          <a:p>
-            <a:pPr algn="l">
-              <a:lnSpc>
-                <a:spcPct val="115000"/>
-              </a:lnSpc>
-              <a:spcAft>
-                <a:spcPts val="400"/>
-              </a:spcAft>
-            </a:pPr>
-            <a:r>
-              <a:rPr sz="1100" b="1">
-                <a:solidFill>
-                  <a:srgbClr val="E67E22"/>
-                </a:solidFill>
-                <a:latin typeface="Calibri"/>
-              </a:rPr>
-              <a:t>▸  </a:t>
-            </a:r>
-            <a:r>
-              <a:rPr sz="1100" b="1">
-                <a:solidFill>
-                  <a:srgbClr val="1E3A5F"/>
-                </a:solidFill>
-                <a:latin typeface="Calibri"/>
-              </a:rPr>
-              <a:t>UP TO N ROWS + WHERE is rejected.</a:t>
-            </a:r>
-            <a:r>
-              <a:rPr sz="1100">
-                <a:solidFill>
-                  <a:srgbClr val="333333"/>
-                </a:solidFill>
-                <a:latin typeface="Calibri"/>
-              </a:rPr>
-              <a:t>  Use the rows parameter on query_sql instead — always safe.</a:t>
-            </a:r>
-          </a:p>
-          <a:p>
-            <a:pPr algn="l">
-              <a:lnSpc>
-                <a:spcPct val="115000"/>
-              </a:lnSpc>
-              <a:spcAft>
-                <a:spcPts val="400"/>
-              </a:spcAft>
-            </a:pPr>
-            <a:r>
-              <a:rPr sz="1100" b="1">
-                <a:solidFill>
-                  <a:srgbClr val="E67E22"/>
-                </a:solidFill>
-                <a:latin typeface="Calibri"/>
-              </a:rPr>
-              <a:t>▸  </a:t>
-            </a:r>
-            <a:r>
-              <a:rPr sz="1100" b="1">
-                <a:solidFill>
-                  <a:srgbClr val="1E3A5F"/>
-                </a:solidFill>
-                <a:latin typeface="Calibri"/>
-              </a:rPr>
-              <a:t>APS_IAM_W_BUC is not directly queryable.</a:t>
-            </a:r>
-            <a:r>
-              <a:rPr sz="1100">
-                <a:solidFill>
-                  <a:srgbClr val="333333"/>
-                </a:solidFill>
-                <a:latin typeface="Calibri"/>
-              </a:rPr>
-              <a:t>  Use CDS view I_APS_BUSINESS_CATALOG (preferred), or raw APS_IAM_W_BRTBUC / W_BC_APP.</a:t>
-            </a:r>
-          </a:p>
-          <a:p>
-            <a:pPr algn="l">
-              <a:lnSpc>
-                <a:spcPct val="115000"/>
-              </a:lnSpc>
-              <a:spcAft>
-                <a:spcPts val="400"/>
-              </a:spcAft>
-            </a:pPr>
-            <a:r>
-              <a:rPr sz="1100" b="1">
-                <a:solidFill>
-                  <a:srgbClr val="E67E22"/>
-                </a:solidFill>
-                <a:latin typeface="Calibri"/>
-              </a:rPr>
-              <a:t>▸  </a:t>
-            </a:r>
-            <a:r>
-              <a:rPr sz="1100" b="1">
-                <a:solidFill>
-                  <a:srgbClr val="1E3A5F"/>
-                </a:solidFill>
-                <a:latin typeface="Calibri"/>
-              </a:rPr>
-              <a:t>SUI_TM_MM_APP stores Treasury app IDs as GUIDs.</a:t>
-            </a:r>
-            <a:r>
-              <a:rPr sz="1100">
-                <a:solidFill>
-                  <a:srgbClr val="333333"/>
-                </a:solidFill>
-                <a:latin typeface="Calibri"/>
-              </a:rPr>
-              <a:t>  Use APS_IAM_W_BC_APP for app-name lookups.</a:t>
-            </a:r>
-          </a:p>
-          <a:p>
-            <a:pPr algn="l">
-              <a:lnSpc>
-                <a:spcPct val="115000"/>
-              </a:lnSpc>
-              <a:spcAft>
-                <a:spcPts val="400"/>
-              </a:spcAft>
-            </a:pPr>
-            <a:r>
-              <a:rPr sz="1100" b="1">
-                <a:solidFill>
-                  <a:srgbClr val="E67E22"/>
-                </a:solidFill>
-                <a:latin typeface="Calibri"/>
-              </a:rPr>
-              <a:t>▸  </a:t>
-            </a:r>
-            <a:r>
-              <a:rPr sz="1100" b="1">
-                <a:solidFill>
-                  <a:srgbClr val="1E3A5F"/>
-                </a:solidFill>
-                <a:latin typeface="Calibri"/>
-              </a:rPr>
-              <a:t>Active vs superseded instances.</a:t>
-            </a:r>
-            <a:r>
-              <a:rPr sz="1100">
-                <a:solidFill>
-                  <a:srgbClr val="333333"/>
-                </a:solidFill>
-                <a:latin typeface="Calibri"/>
-              </a:rPr>
-              <a:t>  INACTIVE = blank means active; INACTIVE = 'X' means superseded.</a:t>
-            </a:r>
-          </a:p>
-        </p:txBody>
-      </p:sp>
+              <a:t>sap-wiki MCP  ·  SAP Confluence research (available in CLI and Web UI — SAP internal network required)</a:t>
+            </a:r>
+          </a:p>
+        </p:txBody>
+      </p:sp>
+      <p:graphicFrame>
+        <p:nvGraphicFramePr>
+          <p:cNvPr id="8" name="Table 7"/>
+          <p:cNvGraphicFramePr>
+            <a:graphicFrameLocks noGrp="1"/>
+          </p:cNvGraphicFramePr>
+          <p:nvPr/>
+        </p:nvGraphicFramePr>
+        <p:xfrm>
+          <a:off x="365760" y="4297680"/>
+          <a:ext cx="11430000" cy="1417320"/>
+        </p:xfrm>
+        <a:graphic>
+          <a:graphicData uri="http://schemas.openxmlformats.org/drawingml/2006/table">
+            <a:tbl>
+              <a:tblPr firstRow="1" bandRow="1">
+                <a:tableStyleId>{5C22544A-7EE6-4342-B048-85BDC9FD1C3A}</a:tableStyleId>
+              </a:tblPr>
+              <a:tblGrid>
+                <a:gridCol w="5715000"/>
+                <a:gridCol w="5715000"/>
+              </a:tblGrid>
+              <a:tr h="283464">
+                <a:tc>
+                  <a:txBody>
+                    <a:bodyPr lIns="73152" rIns="73152"/>
+                    <a:lstStyle/>
+                    <a:p>
+                      <a:pPr algn="l"/>
+                      <a:r>
+                        <a:rPr sz="1200" b="1">
+                          <a:solidFill>
+                            <a:srgbClr val="FFFFFF"/>
+                          </a:solidFill>
+                          <a:latin typeface="Calibri"/>
+                        </a:rPr>
+                        <a:t>Tool</a:t>
+                      </a:r>
+                    </a:p>
+                  </a:txBody>
+                  <a:tcPr>
+                    <a:solidFill>
+                      <a:srgbClr val="1E3A5F"/>
+                    </a:solidFill>
+                  </a:tcPr>
+                </a:tc>
+                <a:tc>
+                  <a:txBody>
+                    <a:bodyPr lIns="73152" rIns="73152"/>
+                    <a:lstStyle/>
+                    <a:p>
+                      <a:pPr algn="l"/>
+                      <a:r>
+                        <a:rPr sz="1200" b="1">
+                          <a:solidFill>
+                            <a:srgbClr val="FFFFFF"/>
+                          </a:solidFill>
+                          <a:latin typeface="Calibri"/>
+                        </a:rPr>
+                        <a:t>Purpose</a:t>
+                      </a:r>
+                    </a:p>
+                  </a:txBody>
+                  <a:tcPr>
+                    <a:solidFill>
+                      <a:srgbClr val="1E3A5F"/>
+                    </a:solidFill>
+                  </a:tcPr>
+                </a:tc>
+              </a:tr>
+              <a:tr h="283464">
+                <a:tc>
+                  <a:txBody>
+                    <a:bodyPr lIns="73152" rIns="73152" tIns="36576" bIns="36576" wrap="square"/>
+                    <a:lstStyle/>
+                    <a:p>
+                      <a:pPr algn="l"/>
+                      <a:r>
+                        <a:rPr sz="1100">
+                          <a:solidFill>
+                            <a:srgbClr val="333333"/>
+                          </a:solidFill>
+                          <a:latin typeface="Calibri"/>
+                        </a:rPr>
+                        <a:t>mcp__sap-wiki__general_search</a:t>
+                      </a:r>
+                    </a:p>
+                  </a:txBody>
+                  <a:tcPr>
+                    <a:solidFill>
+                      <a:srgbClr val="FFFFFF"/>
+                    </a:solidFill>
+                  </a:tcPr>
+                </a:tc>
+                <a:tc>
+                  <a:txBody>
+                    <a:bodyPr lIns="73152" rIns="73152" tIns="36576" bIns="36576" wrap="square"/>
+                    <a:lstStyle/>
+                    <a:p>
+                      <a:pPr algn="l"/>
+                      <a:r>
+                        <a:rPr sz="1100">
+                          <a:solidFill>
+                            <a:srgbClr val="333333"/>
+                          </a:solidFill>
+                          <a:latin typeface="Calibri"/>
+                        </a:rPr>
+                        <a:t>Keyword search across SAP Confluence</a:t>
+                      </a:r>
+                    </a:p>
+                  </a:txBody>
+                  <a:tcPr>
+                    <a:solidFill>
+                      <a:srgbClr val="FFFFFF"/>
+                    </a:solidFill>
+                  </a:tcPr>
+                </a:tc>
+              </a:tr>
+              <a:tr h="283464">
+                <a:tc>
+                  <a:txBody>
+                    <a:bodyPr lIns="73152" rIns="73152" tIns="36576" bIns="36576" wrap="square"/>
+                    <a:lstStyle/>
+                    <a:p>
+                      <a:pPr algn="l"/>
+                      <a:r>
+                        <a:rPr sz="1100">
+                          <a:solidFill>
+                            <a:srgbClr val="333333"/>
+                          </a:solidFill>
+                          <a:latin typeface="Calibri"/>
+                        </a:rPr>
+                        <a:t>mcp__sap-wiki__cql_search</a:t>
+                      </a:r>
+                    </a:p>
+                  </a:txBody>
+                  <a:tcPr>
+                    <a:solidFill>
+                      <a:srgbClr val="F7F9FB"/>
+                    </a:solidFill>
+                  </a:tcPr>
+                </a:tc>
+                <a:tc>
+                  <a:txBody>
+                    <a:bodyPr lIns="73152" rIns="73152" tIns="36576" bIns="36576" wrap="square"/>
+                    <a:lstStyle/>
+                    <a:p>
+                      <a:pPr algn="l"/>
+                      <a:r>
+                        <a:rPr sz="1100">
+                          <a:solidFill>
+                            <a:srgbClr val="333333"/>
+                          </a:solidFill>
+                          <a:latin typeface="Calibri"/>
+                        </a:rPr>
+                        <a:t>Advanced CQL query search</a:t>
+                      </a:r>
+                    </a:p>
+                  </a:txBody>
+                  <a:tcPr>
+                    <a:solidFill>
+                      <a:srgbClr val="F7F9FB"/>
+                    </a:solidFill>
+                  </a:tcPr>
+                </a:tc>
+              </a:tr>
+              <a:tr h="283464">
+                <a:tc>
+                  <a:txBody>
+                    <a:bodyPr lIns="73152" rIns="73152" tIns="36576" bIns="36576" wrap="square"/>
+                    <a:lstStyle/>
+                    <a:p>
+                      <a:pPr algn="l"/>
+                      <a:r>
+                        <a:rPr sz="1100">
+                          <a:solidFill>
+                            <a:srgbClr val="333333"/>
+                          </a:solidFill>
+                          <a:latin typeface="Calibri"/>
+                        </a:rPr>
+                        <a:t>mcp__sap-wiki__wiki_content</a:t>
+                      </a:r>
+                    </a:p>
+                  </a:txBody>
+                  <a:tcPr>
+                    <a:solidFill>
+                      <a:srgbClr val="FFFFFF"/>
+                    </a:solidFill>
+                  </a:tcPr>
+                </a:tc>
+                <a:tc>
+                  <a:txBody>
+                    <a:bodyPr lIns="73152" rIns="73152" tIns="36576" bIns="36576" wrap="square"/>
+                    <a:lstStyle/>
+                    <a:p>
+                      <a:pPr algn="l"/>
+                      <a:r>
+                        <a:rPr sz="1100">
+                          <a:solidFill>
+                            <a:srgbClr val="333333"/>
+                          </a:solidFill>
+                          <a:latin typeface="Calibri"/>
+                        </a:rPr>
+                        <a:t>Fetch full page content by URL</a:t>
+                      </a:r>
+                    </a:p>
+                  </a:txBody>
+                  <a:tcPr>
+                    <a:solidFill>
+                      <a:srgbClr val="FFFFFF"/>
+                    </a:solidFill>
+                  </a:tcPr>
+                </a:tc>
+              </a:tr>
+              <a:tr h="283464">
+                <a:tc>
+                  <a:txBody>
+                    <a:bodyPr lIns="73152" rIns="73152" tIns="36576" bIns="36576" wrap="square"/>
+                    <a:lstStyle/>
+                    <a:p>
+                      <a:pPr algn="l"/>
+                      <a:r>
+                        <a:rPr sz="1100">
+                          <a:solidFill>
+                            <a:srgbClr val="333333"/>
+                          </a:solidFill>
+                          <a:latin typeface="Calibri"/>
+                        </a:rPr>
+                        <a:t>mcp__sap-wiki__cql_examples</a:t>
+                      </a:r>
+                    </a:p>
+                  </a:txBody>
+                  <a:tcPr>
+                    <a:solidFill>
+                      <a:srgbClr val="F7F9FB"/>
+                    </a:solidFill>
+                  </a:tcPr>
+                </a:tc>
+                <a:tc>
+                  <a:txBody>
+                    <a:bodyPr lIns="73152" rIns="73152" tIns="36576" bIns="36576" wrap="square"/>
+                    <a:lstStyle/>
+                    <a:p>
+                      <a:pPr algn="l"/>
+                      <a:r>
+                        <a:rPr sz="1100">
+                          <a:solidFill>
+                            <a:srgbClr val="333333"/>
+                          </a:solidFill>
+                          <a:latin typeface="Calibri"/>
+                        </a:rPr>
+                        <a:t>Get CQL syntax examples and reference</a:t>
+                      </a:r>
+                    </a:p>
+                  </a:txBody>
+                  <a:tcPr>
+                    <a:solidFill>
+                      <a:srgbClr val="F7F9FB"/>
+                    </a:solidFill>
+                  </a:tcPr>
+                </a:tc>
+              </a:tr>
+            </a:tbl>
+          </a:graphicData>
+        </a:graphic>
+      </p:graphicFrame>
       <p:sp>
         <p:nvSpPr>
           <p:cNvPr id="9" name="TextBox 8"/>

</xml_diff>